<commit_message>
Refactor swimlane PPTX generation to reflect updated architecture; add new lanes for deterministic metrics, reshape process, and output. Update speaker notes for clarity and detail. Introduce new infographic rendering script and update HTML content for consistency with the new architecture. Add sequence diagram for visual representation of the algorithm pipeline.
</commit_message>
<xml_diff>
--- a/docs/Burnout-Pipeline-Sequence.pptx
+++ b/docs/Burnout-Pipeline-Sequence.pptx
@@ -502,43 +502,64 @@
           <a:lstStyle/>
           <a:p>
             <a:r>
-              <a:t>This slide shows the six-stage deterministic pipeline in execution order.</a:t>
+              <a:t>This slide shows the seven-stage pipeline in execution order. Stages 1–4 (deterministic metrics) and stage 5 (deterministic pre-pass) require no LLM. Stage 6 is the only AI step. Stage 7 closes the loop.</a:t>
             </a:r>
           </a:p>
           <a:p/>
           <a:p>
             <a:r>
-              <a:t>Stage 1 — Ingestion: GitHub issues are pulled into a versioned in-memory cache via authenticated MCP sync, the rate-limited public API, or the seed endpoint.</a:t>
+              <a:t>Stage 1 — Ingestion: GitHub issues are pulled into a versioned in-memory IssueCache via authenticated MCP sync, the rate-limited /demo/api/sync public endpoint, or the /demo/api/seed test endpoint.</a:t>
             </a:r>
           </a:p>
           <a:p/>
           <a:p>
             <a:r>
-              <a:t>Stage 2 — Chaos Metrics: Five boolean signals are evaluated first — mystery meat, unresolved urgents, context switching, after-hours activity, and label sprawl — producing a chaos score from 0 to 10. This runs BEFORE classification.</a:t>
+              <a:t>Stage 2 — Chaos Metrics: ChaosMetricsService evaluates five binary signals first — mystery meat (≥3 empty bodies), unresolved urgents (≥3), context switching (≥6 in 60 min), after-hours activity, label sprawl (≥12 distinct labels) — producing a chaos score from 0 to 10. Runs BEFORE classification.</a:t>
             </a:r>
           </a:p>
           <a:p/>
           <a:p>
             <a:r>
-              <a:t>Stage 3 — Classification &amp; Compliance: Each issue is sorted into one of four buckets (deep work, quick win, maintenance, deferred) and checked against eight compliance rules. The 3-3-3 day plan is also built here, with classification running a second time internally.</a:t>
+              <a:t>Stage 3 — Classification &amp; Compliance: IssueClassifierService sorts each issue into one of four buckets (deep work, quick win, maintenance, deferred) using first-match-wins label rules. ComplianceService checks 8 violation rules (score 100 → 0). The 3-3-3 day plan is built here as well.</a:t>
             </a:r>
           </a:p>
           <a:p/>
           <a:p>
             <a:r>
-              <a:t>Stage 4 — Stress Score: The WorldState aggregates chaos metrics, classification counts, and compliance into 12 capped variables. Six components (workload, chaos, context switching, clarity, sustained load, after-hours) are summed to produce a score from 0 to 100.</a:t>
+              <a:t>Stage 4 — Stress Score (BEFORE): WorldState aggregates chaos + classification + compliance into 12 capped variables. Six components are summed: Workload (0–40), Chaos (0–30), Context Switching (0–15), Clarity (0–10), Sustained (0–15), After Hours (0–10). Total capped at 100. This is the BEFORE score the demo starts at (~58).</a:t>
             </a:r>
           </a:p>
           <a:p/>
           <a:p>
             <a:r>
-              <a:t>Stage 5 — AI Agents: Only on reshape. A LangChain4j supervisor receives the fully-calculated WorldState and orchestrates five sub-agents that recommend label mutations. Every agent has a deterministic fallback when the LLM is unavailable.</a:t>
+              <a:t>Stage 5 — Deterministic Pre-pass (reshape only, no LLM): BurnoutSupervisorService runs two deterministic methods BEFORE any agent is invoked:</a:t>
+            </a:r>
+          </a:p>
+          <a:p>
+            <a:r>
+              <a:t>  • triageUrgent(n) is called directly for every unassigned-urgent issue, stripping the     `urgent` / `priority:critical` / `priority:high` labels and adding `triaged,backlog`.</a:t>
+            </a:r>
+          </a:p>
+          <a:p>
+            <a:r>
+              <a:t>  • defuseChaosInputs(clock) replaces empty bodies with a scope-pending placeholder and     normalises after-hours / touched-today timestamps to 10:00 in the demo clock zone.</a:t>
+            </a:r>
+          </a:p>
+          <a:p>
+            <a:r>
+              <a:t>These two calls guarantee the chaos score drops on every reshape, regardless of which sub-agents the LLM picks. Without this stage the demo's 58 → 8 drop would not be reliable.</a:t>
             </a:r>
           </a:p>
           <a:p/>
           <a:p>
             <a:r>
-              <a:t>Stage 6 — Output: Mutations are applied to the in-memory cache (not GitHub directly). Stress is recalculated on the mutated issues to show the drop. A Friday deploy score assesses release readiness. Every check-in is persisted as a JPA snapshot for longitudinal tracking.</a:t>
+              <a:t>Stage 6 — Supervisor + 6 Sub-Agents (reshape only, AI): AgenticServices.supervisorBuilder() with maxAgentsInvocations=15 and SupervisorResponseStrategy.SUMMARY orchestrates six sub-agents — TriageAgent, DeferAgent, DelegateAgent, ClassifyAgent, ScopeAgent, WellnessAgent — each backed by @Tool methods on BurnoutMutationTool that emit sealed GitHubAction records (AddLabels, RemoveLabels, Comment, Unassign, SetBody, SetUpdatedAt). Every agent has a deterministic fallback when the LLM is unavailable.</a:t>
+            </a:r>
+          </a:p>
+          <a:p/>
+          <a:p>
+            <a:r>
+              <a:t>Stage 7 — Output: Mutations are applied to the in-memory IssueCache (not to GitHub). The ENTIRE deterministic pipeline (stages 2–4) reruns on the mutated issues to produce the AFTER score (~8 in the demo). A Friday deploy score assesses release readiness (READY ≥ 80, CAUTION ≥ 50, NOT_READY &lt; 50). Every check-in is persisted as a JPA StressSnapshot for the longitudinal Study Dashboard.</a:t>
             </a:r>
           </a:p>
         </p:txBody>
@@ -3554,13 +3575,197 @@
       <p:grpSpPr/>
       <p:sp>
         <p:nvSpPr>
+          <p:cNvPr id="7" name="Rectangle 6"/>
+          <p:cNvSpPr/>
+          <p:nvPr/>
+        </p:nvSpPr>
+        <p:spPr>
+          <a:xfrm>
+            <a:off x="10343235" y="2011680"/>
+            <a:ext cx="1655064" cy="3337560"/>
+          </a:xfrm>
+          <a:prstGeom prst="rect">
+            <a:avLst/>
+          </a:prstGeom>
+          <a:solidFill>
+            <a:srgbClr val="0E0F1B"/>
+          </a:solidFill>
+          <a:ln w="6350">
+            <a:solidFill>
+              <a:srgbClr val="20233E"/>
+            </a:solidFill>
+          </a:ln>
+          <a:effectLst/>
+        </p:spPr>
+        <p:style>
+          <a:lnRef idx="1">
+            <a:schemeClr val="accent1"/>
+          </a:lnRef>
+          <a:fillRef idx="3">
+            <a:schemeClr val="accent1"/>
+          </a:fillRef>
+          <a:effectRef idx="2">
+            <a:schemeClr val="accent1"/>
+          </a:effectRef>
+          <a:fontRef idx="minor">
+            <a:schemeClr val="lt1"/>
+          </a:fontRef>
+        </p:style>
+        <p:txBody>
+          <a:bodyPr rtlCol="0" anchor="ctr"/>
+          <a:lstStyle/>
+          <a:p>
+            <a:pPr algn="ctr"/>
+          </a:p>
+        </p:txBody>
+      </p:sp>
+      <p:sp>
+        <p:nvSpPr>
+          <p:cNvPr id="6" name="Rectangle 5"/>
+          <p:cNvSpPr/>
+          <p:nvPr/>
+        </p:nvSpPr>
+        <p:spPr>
+          <a:xfrm>
+            <a:off x="8651595" y="2011680"/>
+            <a:ext cx="1655064" cy="3337560"/>
+          </a:xfrm>
+          <a:prstGeom prst="rect">
+            <a:avLst/>
+          </a:prstGeom>
+          <a:solidFill>
+            <a:srgbClr val="1B0C0E"/>
+          </a:solidFill>
+          <a:ln w="6350">
+            <a:solidFill>
+              <a:srgbClr val="3E1C21"/>
+            </a:solidFill>
+          </a:ln>
+          <a:effectLst/>
+        </p:spPr>
+        <p:style>
+          <a:lnRef idx="1">
+            <a:schemeClr val="accent1"/>
+          </a:lnRef>
+          <a:fillRef idx="3">
+            <a:schemeClr val="accent1"/>
+          </a:fillRef>
+          <a:effectRef idx="2">
+            <a:schemeClr val="accent1"/>
+          </a:effectRef>
+          <a:fontRef idx="minor">
+            <a:schemeClr val="lt1"/>
+          </a:fontRef>
+        </p:style>
+        <p:txBody>
+          <a:bodyPr rtlCol="0" anchor="ctr"/>
+          <a:lstStyle/>
+          <a:p>
+            <a:pPr algn="ctr"/>
+          </a:p>
+        </p:txBody>
+      </p:sp>
+      <p:sp>
+        <p:nvSpPr>
+          <p:cNvPr id="5" name="Rectangle 4"/>
+          <p:cNvSpPr/>
+          <p:nvPr/>
+        </p:nvSpPr>
+        <p:spPr>
+          <a:xfrm>
+            <a:off x="6959955" y="2011680"/>
+            <a:ext cx="1655064" cy="3337560"/>
+          </a:xfrm>
+          <a:prstGeom prst="rect">
+            <a:avLst/>
+          </a:prstGeom>
+          <a:solidFill>
+            <a:srgbClr val="051715"/>
+          </a:solidFill>
+          <a:ln w="6350">
+            <a:solidFill>
+              <a:srgbClr val="0B352F"/>
+            </a:solidFill>
+          </a:ln>
+          <a:effectLst/>
+        </p:spPr>
+        <p:style>
+          <a:lnRef idx="1">
+            <a:schemeClr val="accent1"/>
+          </a:lnRef>
+          <a:fillRef idx="3">
+            <a:schemeClr val="accent1"/>
+          </a:fillRef>
+          <a:effectRef idx="2">
+            <a:schemeClr val="accent1"/>
+          </a:effectRef>
+          <a:fontRef idx="minor">
+            <a:schemeClr val="lt1"/>
+          </a:fontRef>
+        </p:style>
+        <p:txBody>
+          <a:bodyPr rtlCol="0" anchor="ctr"/>
+          <a:lstStyle/>
+          <a:p>
+            <a:pPr algn="ctr"/>
+          </a:p>
+        </p:txBody>
+      </p:sp>
+      <p:sp>
+        <p:nvSpPr>
+          <p:cNvPr id="4" name="Rectangle 3"/>
+          <p:cNvSpPr/>
+          <p:nvPr/>
+        </p:nvSpPr>
+        <p:spPr>
+          <a:xfrm>
+            <a:off x="193395" y="2011680"/>
+            <a:ext cx="6729984" cy="3337560"/>
+          </a:xfrm>
+          <a:prstGeom prst="rect">
+            <a:avLst/>
+          </a:prstGeom>
+          <a:solidFill>
+            <a:srgbClr val="051715"/>
+          </a:solidFill>
+          <a:ln w="6350">
+            <a:solidFill>
+              <a:srgbClr val="0B352F"/>
+            </a:solidFill>
+          </a:ln>
+          <a:effectLst/>
+        </p:spPr>
+        <p:style>
+          <a:lnRef idx="1">
+            <a:schemeClr val="accent1"/>
+          </a:lnRef>
+          <a:fillRef idx="3">
+            <a:schemeClr val="accent1"/>
+          </a:fillRef>
+          <a:effectRef idx="2">
+            <a:schemeClr val="accent1"/>
+          </a:effectRef>
+          <a:fontRef idx="minor">
+            <a:schemeClr val="lt1"/>
+          </a:fontRef>
+        </p:style>
+        <p:txBody>
+          <a:bodyPr rtlCol="0" anchor="ctr"/>
+          <a:lstStyle/>
+          <a:p>
+            <a:pPr algn="ctr"/>
+          </a:p>
+        </p:txBody>
+      </p:sp>
+      <p:sp>
+        <p:nvSpPr>
           <p:cNvPr id="2" name="TextBox 1"/>
           <p:cNvSpPr txBox="1"/>
           <p:nvPr/>
         </p:nvSpPr>
         <p:spPr>
           <a:xfrm>
-            <a:off x="0" y="548640"/>
+            <a:off x="0" y="457200"/>
             <a:ext cx="12191695" cy="640080"/>
           </a:xfrm>
           <a:prstGeom prst="rect">
@@ -3596,7 +3801,7 @@
         </p:nvSpPr>
         <p:spPr>
           <a:xfrm>
-            <a:off x="0" y="1143000"/>
+            <a:off x="0" y="1051560"/>
             <a:ext cx="12191695" cy="365760"/>
           </a:xfrm>
           <a:prstGeom prst="rect">
@@ -3611,7 +3816,7 @@
           <a:lstStyle/>
           <a:p>
             <a:pPr algn="ctr">
-              <a:defRPr sz="1400">
+              <a:defRPr sz="1300">
                 <a:solidFill>
                   <a:srgbClr val="94A3B8"/>
                 </a:solidFill>
@@ -3619,21 +3824,165 @@
               </a:defRPr>
             </a:pPr>
             <a:r>
-              <a:t>Deterministic services compute all metrics  •  AI agents only explain &amp; act  •  Every agent has a fallback</a:t>
-            </a:r>
-          </a:p>
-        </p:txBody>
-      </p:sp>
-      <p:sp>
-        <p:nvSpPr>
-          <p:cNvPr id="4" name="Rounded Rectangle 3"/>
+              <a:t>Deterministic services compute every metric  •  Pre-pass guarantees the drop  •  AI agents only rebalance, never decide alone</a:t>
+            </a:r>
+          </a:p>
+        </p:txBody>
+      </p:sp>
+      <p:sp>
+        <p:nvSpPr>
+          <p:cNvPr id="8" name="TextBox 7"/>
+          <p:cNvSpPr txBox="1"/>
+          <p:nvPr/>
+        </p:nvSpPr>
+        <p:spPr>
+          <a:xfrm>
+            <a:off x="193395" y="1691640"/>
+            <a:ext cx="6729984" cy="274320"/>
+          </a:xfrm>
+          <a:prstGeom prst="rect">
+            <a:avLst/>
+          </a:prstGeom>
+          <a:noFill/>
+        </p:spPr>
+        <p:txBody>
+          <a:bodyPr wrap="square">
+            <a:spAutoFit/>
+          </a:bodyPr>
+          <a:lstStyle/>
+          <a:p>
+            <a:pPr algn="ctr">
+              <a:defRPr sz="1100" b="1">
+                <a:solidFill>
+                  <a:srgbClr val="2DD4BF"/>
+                </a:solidFill>
+                <a:latin typeface="Segoe UI"/>
+              </a:defRPr>
+            </a:pPr>
+            <a:r>
+              <a:t>DETERMINISTIC  ·  metrics</a:t>
+            </a:r>
+          </a:p>
+        </p:txBody>
+      </p:sp>
+      <p:sp>
+        <p:nvSpPr>
+          <p:cNvPr id="9" name="TextBox 8"/>
+          <p:cNvSpPr txBox="1"/>
+          <p:nvPr/>
+        </p:nvSpPr>
+        <p:spPr>
+          <a:xfrm>
+            <a:off x="6959955" y="1691640"/>
+            <a:ext cx="1655064" cy="274320"/>
+          </a:xfrm>
+          <a:prstGeom prst="rect">
+            <a:avLst/>
+          </a:prstGeom>
+          <a:noFill/>
+        </p:spPr>
+        <p:txBody>
+          <a:bodyPr wrap="square">
+            <a:spAutoFit/>
+          </a:bodyPr>
+          <a:lstStyle/>
+          <a:p>
+            <a:pPr algn="ctr">
+              <a:defRPr sz="1100" b="1">
+                <a:solidFill>
+                  <a:srgbClr val="2DD4BF"/>
+                </a:solidFill>
+                <a:latin typeface="Segoe UI"/>
+              </a:defRPr>
+            </a:pPr>
+            <a:r>
+              <a:t>DETERMINISTIC  ·  pre-pass</a:t>
+            </a:r>
+          </a:p>
+        </p:txBody>
+      </p:sp>
+      <p:sp>
+        <p:nvSpPr>
+          <p:cNvPr id="10" name="TextBox 9"/>
+          <p:cNvSpPr txBox="1"/>
+          <p:nvPr/>
+        </p:nvSpPr>
+        <p:spPr>
+          <a:xfrm>
+            <a:off x="8651595" y="1691640"/>
+            <a:ext cx="1655064" cy="274320"/>
+          </a:xfrm>
+          <a:prstGeom prst="rect">
+            <a:avLst/>
+          </a:prstGeom>
+          <a:noFill/>
+        </p:spPr>
+        <p:txBody>
+          <a:bodyPr wrap="square">
+            <a:spAutoFit/>
+          </a:bodyPr>
+          <a:lstStyle/>
+          <a:p>
+            <a:pPr algn="ctr">
+              <a:defRPr sz="1100" b="1">
+                <a:solidFill>
+                  <a:srgbClr val="FB7185"/>
+                </a:solidFill>
+                <a:latin typeface="Segoe UI"/>
+              </a:defRPr>
+            </a:pPr>
+            <a:r>
+              <a:t>AI</a:t>
+            </a:r>
+          </a:p>
+        </p:txBody>
+      </p:sp>
+      <p:sp>
+        <p:nvSpPr>
+          <p:cNvPr id="11" name="TextBox 10"/>
+          <p:cNvSpPr txBox="1"/>
+          <p:nvPr/>
+        </p:nvSpPr>
+        <p:spPr>
+          <a:xfrm>
+            <a:off x="10343235" y="1691640"/>
+            <a:ext cx="1655064" cy="274320"/>
+          </a:xfrm>
+          <a:prstGeom prst="rect">
+            <a:avLst/>
+          </a:prstGeom>
+          <a:noFill/>
+        </p:spPr>
+        <p:txBody>
+          <a:bodyPr wrap="square">
+            <a:spAutoFit/>
+          </a:bodyPr>
+          <a:lstStyle/>
+          <a:p>
+            <a:pPr algn="ctr">
+              <a:defRPr sz="1100" b="1">
+                <a:solidFill>
+                  <a:srgbClr val="818CF8"/>
+                </a:solidFill>
+                <a:latin typeface="Segoe UI"/>
+              </a:defRPr>
+            </a:pPr>
+            <a:r>
+              <a:t>OUTPUT</a:t>
+            </a:r>
+          </a:p>
+        </p:txBody>
+      </p:sp>
+      <p:sp>
+        <p:nvSpPr>
+          <p:cNvPr id="12" name="Rounded Rectangle 11"/>
           <p:cNvSpPr/>
           <p:nvPr/>
         </p:nvSpPr>
         <p:spPr>
           <a:xfrm>
-            <a:off x="426567" y="2194560"/>
-            <a:ext cx="1508760" cy="2743200"/>
+            <a:off x="357987" y="2194560"/>
+            <a:ext cx="1325880" cy="2926080"/>
           </a:xfrm>
           <a:prstGeom prst="roundRect">
             <a:avLst>
@@ -3674,13 +4023,13 @@
       </p:sp>
       <p:sp>
         <p:nvSpPr>
-          <p:cNvPr id="5" name="Oval 4"/>
+          <p:cNvPr id="13" name="Oval 12"/>
           <p:cNvSpPr/>
           <p:nvPr/>
         </p:nvSpPr>
         <p:spPr>
           <a:xfrm>
-            <a:off x="929487" y="2468880"/>
+            <a:off x="769467" y="2468880"/>
             <a:ext cx="502920" cy="502920"/>
           </a:xfrm>
           <a:prstGeom prst="ellipse">
@@ -3734,14 +4083,14 @@
       </p:sp>
       <p:sp>
         <p:nvSpPr>
-          <p:cNvPr id="6" name="TextBox 5"/>
+          <p:cNvPr id="14" name="TextBox 13"/>
           <p:cNvSpPr txBox="1"/>
           <p:nvPr/>
         </p:nvSpPr>
         <p:spPr>
           <a:xfrm>
-            <a:off x="518007" y="3154680"/>
-            <a:ext cx="1325880" cy="457200"/>
+            <a:off x="431139" y="3154680"/>
+            <a:ext cx="1179576" cy="594360"/>
           </a:xfrm>
           <a:prstGeom prst="rect">
             <a:avLst/>
@@ -3755,7 +4104,7 @@
           <a:lstStyle/>
           <a:p>
             <a:pPr algn="ctr">
-              <a:defRPr sz="1500" b="1">
+              <a:defRPr sz="1400" b="1">
                 <a:solidFill>
                   <a:srgbClr val="F8FAFC"/>
                 </a:solidFill>
@@ -3770,14 +4119,14 @@
       </p:sp>
       <p:sp>
         <p:nvSpPr>
-          <p:cNvPr id="7" name="TextBox 6"/>
+          <p:cNvPr id="15" name="TextBox 14"/>
           <p:cNvSpPr txBox="1"/>
           <p:nvPr/>
         </p:nvSpPr>
         <p:spPr>
           <a:xfrm>
-            <a:off x="518007" y="3657600"/>
-            <a:ext cx="1325880" cy="1097280"/>
+            <a:off x="431139" y="3749040"/>
+            <a:ext cx="1179576" cy="1280160"/>
           </a:xfrm>
           <a:prstGeom prst="rect">
             <a:avLst/>
@@ -3792,9 +4141,9 @@
           <a:p>
             <a:pPr algn="ctr">
               <a:lnSpc>
-                <a:spcPts val="1800"/>
+                <a:spcPts val="1500"/>
               </a:lnSpc>
-              <a:defRPr sz="1300">
+              <a:defRPr sz="1100">
                 <a:solidFill>
                   <a:srgbClr val="94A3B8"/>
                 </a:solidFill>
@@ -3813,14 +4162,14 @@
       </p:sp>
       <p:sp>
         <p:nvSpPr>
-          <p:cNvPr id="8" name="Right Arrow 7"/>
+          <p:cNvPr id="16" name="Right Arrow 15"/>
           <p:cNvSpPr/>
           <p:nvPr/>
         </p:nvSpPr>
         <p:spPr>
           <a:xfrm>
-            <a:off x="1953615" y="3429000"/>
-            <a:ext cx="420624" cy="274320"/>
+            <a:off x="1702155" y="3520440"/>
+            <a:ext cx="329184" cy="274320"/>
           </a:xfrm>
           <a:prstGeom prst="rightArrow">
             <a:avLst/>
@@ -3857,14 +4206,14 @@
       </p:sp>
       <p:sp>
         <p:nvSpPr>
-          <p:cNvPr id="9" name="Rounded Rectangle 8"/>
+          <p:cNvPr id="17" name="Rounded Rectangle 16"/>
           <p:cNvSpPr/>
           <p:nvPr/>
         </p:nvSpPr>
         <p:spPr>
           <a:xfrm>
-            <a:off x="2392527" y="2194560"/>
-            <a:ext cx="1508760" cy="2743200"/>
+            <a:off x="2049627" y="2194560"/>
+            <a:ext cx="1325880" cy="2926080"/>
           </a:xfrm>
           <a:prstGeom prst="roundRect">
             <a:avLst>
@@ -3905,13 +4254,13 @@
       </p:sp>
       <p:sp>
         <p:nvSpPr>
-          <p:cNvPr id="10" name="Oval 9"/>
+          <p:cNvPr id="18" name="Oval 17"/>
           <p:cNvSpPr/>
           <p:nvPr/>
         </p:nvSpPr>
         <p:spPr>
           <a:xfrm>
-            <a:off x="2895447" y="2468880"/>
+            <a:off x="2461107" y="2468880"/>
             <a:ext cx="502920" cy="502920"/>
           </a:xfrm>
           <a:prstGeom prst="ellipse">
@@ -3965,14 +4314,14 @@
       </p:sp>
       <p:sp>
         <p:nvSpPr>
-          <p:cNvPr id="11" name="TextBox 10"/>
+          <p:cNvPr id="19" name="TextBox 18"/>
           <p:cNvSpPr txBox="1"/>
           <p:nvPr/>
         </p:nvSpPr>
         <p:spPr>
           <a:xfrm>
-            <a:off x="2483967" y="3154680"/>
-            <a:ext cx="1325880" cy="457200"/>
+            <a:off x="2122779" y="3154680"/>
+            <a:ext cx="1179576" cy="594360"/>
           </a:xfrm>
           <a:prstGeom prst="rect">
             <a:avLst/>
@@ -3986,7 +4335,7 @@
           <a:lstStyle/>
           <a:p>
             <a:pPr algn="ctr">
-              <a:defRPr sz="1500" b="1">
+              <a:defRPr sz="1400" b="1">
                 <a:solidFill>
                   <a:srgbClr val="F8FAFC"/>
                 </a:solidFill>
@@ -4001,14 +4350,14 @@
       </p:sp>
       <p:sp>
         <p:nvSpPr>
-          <p:cNvPr id="12" name="TextBox 11"/>
+          <p:cNvPr id="20" name="TextBox 19"/>
           <p:cNvSpPr txBox="1"/>
           <p:nvPr/>
         </p:nvSpPr>
         <p:spPr>
           <a:xfrm>
-            <a:off x="2483967" y="3657600"/>
-            <a:ext cx="1325880" cy="1097280"/>
+            <a:off x="2122779" y="3749040"/>
+            <a:ext cx="1179576" cy="1280160"/>
           </a:xfrm>
           <a:prstGeom prst="rect">
             <a:avLst/>
@@ -4023,9 +4372,9 @@
           <a:p>
             <a:pPr algn="ctr">
               <a:lnSpc>
-                <a:spcPts val="1800"/>
+                <a:spcPts val="1500"/>
               </a:lnSpc>
-              <a:defRPr sz="1300">
+              <a:defRPr sz="1100">
                 <a:solidFill>
                   <a:srgbClr val="94A3B8"/>
                 </a:solidFill>
@@ -4044,14 +4393,14 @@
       </p:sp>
       <p:sp>
         <p:nvSpPr>
-          <p:cNvPr id="13" name="Right Arrow 12"/>
+          <p:cNvPr id="21" name="Right Arrow 20"/>
           <p:cNvSpPr/>
           <p:nvPr/>
         </p:nvSpPr>
         <p:spPr>
           <a:xfrm>
-            <a:off x="3919575" y="3429000"/>
-            <a:ext cx="420624" cy="274320"/>
+            <a:off x="3393795" y="3520440"/>
+            <a:ext cx="329184" cy="274320"/>
           </a:xfrm>
           <a:prstGeom prst="rightArrow">
             <a:avLst/>
@@ -4088,14 +4437,14 @@
       </p:sp>
       <p:sp>
         <p:nvSpPr>
-          <p:cNvPr id="14" name="Rounded Rectangle 13"/>
+          <p:cNvPr id="22" name="Rounded Rectangle 21"/>
           <p:cNvSpPr/>
           <p:nvPr/>
         </p:nvSpPr>
         <p:spPr>
           <a:xfrm>
-            <a:off x="4358487" y="2194560"/>
-            <a:ext cx="1508760" cy="2743200"/>
+            <a:off x="3741267" y="2194560"/>
+            <a:ext cx="1325880" cy="2926080"/>
           </a:xfrm>
           <a:prstGeom prst="roundRect">
             <a:avLst>
@@ -4136,13 +4485,13 @@
       </p:sp>
       <p:sp>
         <p:nvSpPr>
-          <p:cNvPr id="15" name="Oval 14"/>
+          <p:cNvPr id="23" name="Oval 22"/>
           <p:cNvSpPr/>
           <p:nvPr/>
         </p:nvSpPr>
         <p:spPr>
           <a:xfrm>
-            <a:off x="4861407" y="2468880"/>
+            <a:off x="4152747" y="2468880"/>
             <a:ext cx="502920" cy="502920"/>
           </a:xfrm>
           <a:prstGeom prst="ellipse">
@@ -4196,14 +4545,14 @@
       </p:sp>
       <p:sp>
         <p:nvSpPr>
-          <p:cNvPr id="16" name="TextBox 15"/>
+          <p:cNvPr id="24" name="TextBox 23"/>
           <p:cNvSpPr txBox="1"/>
           <p:nvPr/>
         </p:nvSpPr>
         <p:spPr>
           <a:xfrm>
-            <a:off x="4449927" y="3154680"/>
-            <a:ext cx="1325880" cy="457200"/>
+            <a:off x="3814419" y="3154680"/>
+            <a:ext cx="1179576" cy="594360"/>
           </a:xfrm>
           <a:prstGeom prst="rect">
             <a:avLst/>
@@ -4217,7 +4566,7 @@
           <a:lstStyle/>
           <a:p>
             <a:pPr algn="ctr">
-              <a:defRPr sz="1500" b="1">
+              <a:defRPr sz="1400" b="1">
                 <a:solidFill>
                   <a:srgbClr val="F8FAFC"/>
                 </a:solidFill>
@@ -4232,14 +4581,14 @@
       </p:sp>
       <p:sp>
         <p:nvSpPr>
-          <p:cNvPr id="17" name="TextBox 16"/>
+          <p:cNvPr id="25" name="TextBox 24"/>
           <p:cNvSpPr txBox="1"/>
           <p:nvPr/>
         </p:nvSpPr>
         <p:spPr>
           <a:xfrm>
-            <a:off x="4449927" y="3657600"/>
-            <a:ext cx="1325880" cy="1097280"/>
+            <a:off x="3814419" y="3749040"/>
+            <a:ext cx="1179576" cy="1280160"/>
           </a:xfrm>
           <a:prstGeom prst="rect">
             <a:avLst/>
@@ -4254,9 +4603,9 @@
           <a:p>
             <a:pPr algn="ctr">
               <a:lnSpc>
-                <a:spcPts val="1800"/>
+                <a:spcPts val="1500"/>
               </a:lnSpc>
-              <a:defRPr sz="1300">
+              <a:defRPr sz="1100">
                 <a:solidFill>
                   <a:srgbClr val="94A3B8"/>
                 </a:solidFill>
@@ -4275,14 +4624,14 @@
       </p:sp>
       <p:sp>
         <p:nvSpPr>
-          <p:cNvPr id="18" name="Right Arrow 17"/>
+          <p:cNvPr id="26" name="Right Arrow 25"/>
           <p:cNvSpPr/>
           <p:nvPr/>
         </p:nvSpPr>
         <p:spPr>
           <a:xfrm>
-            <a:off x="5885535" y="3429000"/>
-            <a:ext cx="420624" cy="274320"/>
+            <a:off x="5085435" y="3520440"/>
+            <a:ext cx="329184" cy="274320"/>
           </a:xfrm>
           <a:prstGeom prst="rightArrow">
             <a:avLst/>
@@ -4319,14 +4668,14 @@
       </p:sp>
       <p:sp>
         <p:nvSpPr>
-          <p:cNvPr id="19" name="Rounded Rectangle 18"/>
+          <p:cNvPr id="27" name="Rounded Rectangle 26"/>
           <p:cNvSpPr/>
           <p:nvPr/>
         </p:nvSpPr>
         <p:spPr>
           <a:xfrm>
-            <a:off x="6324447" y="2194560"/>
-            <a:ext cx="1508760" cy="2743200"/>
+            <a:off x="5432907" y="2194560"/>
+            <a:ext cx="1325880" cy="2926080"/>
           </a:xfrm>
           <a:prstGeom prst="roundRect">
             <a:avLst>
@@ -4367,13 +4716,13 @@
       </p:sp>
       <p:sp>
         <p:nvSpPr>
-          <p:cNvPr id="20" name="Oval 19"/>
+          <p:cNvPr id="28" name="Oval 27"/>
           <p:cNvSpPr/>
           <p:nvPr/>
         </p:nvSpPr>
         <p:spPr>
           <a:xfrm>
-            <a:off x="6827367" y="2468880"/>
+            <a:off x="5844387" y="2468880"/>
             <a:ext cx="502920" cy="502920"/>
           </a:xfrm>
           <a:prstGeom prst="ellipse">
@@ -4427,14 +4776,14 @@
       </p:sp>
       <p:sp>
         <p:nvSpPr>
-          <p:cNvPr id="21" name="TextBox 20"/>
+          <p:cNvPr id="29" name="TextBox 28"/>
           <p:cNvSpPr txBox="1"/>
           <p:nvPr/>
         </p:nvSpPr>
         <p:spPr>
           <a:xfrm>
-            <a:off x="6415887" y="3154680"/>
-            <a:ext cx="1325880" cy="457200"/>
+            <a:off x="5506059" y="3154680"/>
+            <a:ext cx="1179576" cy="594360"/>
           </a:xfrm>
           <a:prstGeom prst="rect">
             <a:avLst/>
@@ -4448,7 +4797,7 @@
           <a:lstStyle/>
           <a:p>
             <a:pPr algn="ctr">
-              <a:defRPr sz="1500" b="1">
+              <a:defRPr sz="1400" b="1">
                 <a:solidFill>
                   <a:srgbClr val="F8FAFC"/>
                 </a:solidFill>
@@ -4463,14 +4812,14 @@
       </p:sp>
       <p:sp>
         <p:nvSpPr>
-          <p:cNvPr id="22" name="TextBox 21"/>
+          <p:cNvPr id="30" name="TextBox 29"/>
           <p:cNvSpPr txBox="1"/>
           <p:nvPr/>
         </p:nvSpPr>
         <p:spPr>
           <a:xfrm>
-            <a:off x="6415887" y="3657600"/>
-            <a:ext cx="1325880" cy="1097280"/>
+            <a:off x="5506059" y="3749040"/>
+            <a:ext cx="1179576" cy="1280160"/>
           </a:xfrm>
           <a:prstGeom prst="rect">
             <a:avLst/>
@@ -4485,9 +4834,9 @@
           <a:p>
             <a:pPr algn="ctr">
               <a:lnSpc>
-                <a:spcPts val="1800"/>
+                <a:spcPts val="1500"/>
               </a:lnSpc>
-              <a:defRPr sz="1300">
+              <a:defRPr sz="1100">
                 <a:solidFill>
                   <a:srgbClr val="94A3B8"/>
                 </a:solidFill>
@@ -4506,14 +4855,14 @@
       </p:sp>
       <p:sp>
         <p:nvSpPr>
-          <p:cNvPr id="23" name="Right Arrow 22"/>
+          <p:cNvPr id="31" name="Right Arrow 30"/>
           <p:cNvSpPr/>
           <p:nvPr/>
         </p:nvSpPr>
         <p:spPr>
           <a:xfrm>
-            <a:off x="7851495" y="3429000"/>
-            <a:ext cx="420624" cy="274320"/>
+            <a:off x="6777075" y="3520440"/>
+            <a:ext cx="329184" cy="274320"/>
           </a:xfrm>
           <a:prstGeom prst="rightArrow">
             <a:avLst/>
@@ -4550,14 +4899,249 @@
       </p:sp>
       <p:sp>
         <p:nvSpPr>
-          <p:cNvPr id="24" name="Rounded Rectangle 23"/>
+          <p:cNvPr id="32" name="Rounded Rectangle 31"/>
           <p:cNvSpPr/>
           <p:nvPr/>
         </p:nvSpPr>
         <p:spPr>
           <a:xfrm>
-            <a:off x="8290407" y="2194560"/>
-            <a:ext cx="1508760" cy="2743200"/>
+            <a:off x="7124547" y="2194560"/>
+            <a:ext cx="1325880" cy="2926080"/>
+          </a:xfrm>
+          <a:prstGeom prst="roundRect">
+            <a:avLst>
+              <a:gd name="adj" fmla="val 10000"/>
+            </a:avLst>
+          </a:prstGeom>
+          <a:solidFill>
+            <a:srgbClr val="092A26"/>
+          </a:solidFill>
+          <a:ln w="19050">
+            <a:solidFill>
+              <a:srgbClr val="2DD4BF"/>
+            </a:solidFill>
+          </a:ln>
+          <a:effectLst/>
+        </p:spPr>
+        <p:style>
+          <a:lnRef idx="1">
+            <a:schemeClr val="accent1"/>
+          </a:lnRef>
+          <a:fillRef idx="3">
+            <a:schemeClr val="accent1"/>
+          </a:fillRef>
+          <a:effectRef idx="2">
+            <a:schemeClr val="accent1"/>
+          </a:effectRef>
+          <a:fontRef idx="minor">
+            <a:schemeClr val="lt1"/>
+          </a:fontRef>
+        </p:style>
+        <p:txBody>
+          <a:bodyPr rtlCol="0" anchor="ctr"/>
+          <a:lstStyle/>
+          <a:p>
+            <a:pPr algn="ctr"/>
+          </a:p>
+        </p:txBody>
+      </p:sp>
+      <p:sp>
+        <p:nvSpPr>
+          <p:cNvPr id="33" name="Oval 32"/>
+          <p:cNvSpPr/>
+          <p:nvPr/>
+        </p:nvSpPr>
+        <p:spPr>
+          <a:xfrm>
+            <a:off x="7536027" y="2468880"/>
+            <a:ext cx="502920" cy="502920"/>
+          </a:xfrm>
+          <a:prstGeom prst="ellipse">
+            <a:avLst/>
+          </a:prstGeom>
+          <a:solidFill>
+            <a:srgbClr val="2DD4BF"/>
+          </a:solidFill>
+          <a:ln>
+            <a:noFill/>
+          </a:ln>
+          <a:effectLst/>
+        </p:spPr>
+        <p:style>
+          <a:lnRef idx="1">
+            <a:schemeClr val="accent1"/>
+          </a:lnRef>
+          <a:fillRef idx="3">
+            <a:schemeClr val="accent1"/>
+          </a:fillRef>
+          <a:effectRef idx="2">
+            <a:schemeClr val="accent1"/>
+          </a:effectRef>
+          <a:fontRef idx="minor">
+            <a:schemeClr val="lt1"/>
+          </a:fontRef>
+        </p:style>
+        <p:txBody>
+          <a:bodyPr rtlCol="0" anchor="ctr" wrap="none"/>
+          <a:lstStyle/>
+          <a:p>
+            <a:pPr algn="ctr">
+              <a:spcBef>
+                <a:spcPts val="0"/>
+              </a:spcBef>
+              <a:spcAft>
+                <a:spcPts val="0"/>
+              </a:spcAft>
+              <a:defRPr sz="2000" b="1">
+                <a:solidFill>
+                  <a:srgbClr val="0F172A"/>
+                </a:solidFill>
+                <a:latin typeface="Segoe UI"/>
+              </a:defRPr>
+            </a:pPr>
+            <a:r>
+              <a:t>5</a:t>
+            </a:r>
+          </a:p>
+        </p:txBody>
+      </p:sp>
+      <p:sp>
+        <p:nvSpPr>
+          <p:cNvPr id="34" name="TextBox 33"/>
+          <p:cNvSpPr txBox="1"/>
+          <p:nvPr/>
+        </p:nvSpPr>
+        <p:spPr>
+          <a:xfrm>
+            <a:off x="7197699" y="3154680"/>
+            <a:ext cx="1179576" cy="594360"/>
+          </a:xfrm>
+          <a:prstGeom prst="rect">
+            <a:avLst/>
+          </a:prstGeom>
+          <a:noFill/>
+        </p:spPr>
+        <p:txBody>
+          <a:bodyPr wrap="square">
+            <a:spAutoFit/>
+          </a:bodyPr>
+          <a:lstStyle/>
+          <a:p>
+            <a:pPr algn="ctr">
+              <a:defRPr sz="1400" b="1">
+                <a:solidFill>
+                  <a:srgbClr val="F8FAFC"/>
+                </a:solidFill>
+                <a:latin typeface="Segoe UI"/>
+              </a:defRPr>
+            </a:pPr>
+            <a:r>
+              <a:t>Pre-pass</a:t>
+            </a:r>
+          </a:p>
+        </p:txBody>
+      </p:sp>
+      <p:sp>
+        <p:nvSpPr>
+          <p:cNvPr id="35" name="TextBox 34"/>
+          <p:cNvSpPr txBox="1"/>
+          <p:nvPr/>
+        </p:nvSpPr>
+        <p:spPr>
+          <a:xfrm>
+            <a:off x="7197699" y="3749040"/>
+            <a:ext cx="1179576" cy="1280160"/>
+          </a:xfrm>
+          <a:prstGeom prst="rect">
+            <a:avLst/>
+          </a:prstGeom>
+          <a:noFill/>
+        </p:spPr>
+        <p:txBody>
+          <a:bodyPr wrap="square">
+            <a:spAutoFit/>
+          </a:bodyPr>
+          <a:lstStyle/>
+          <a:p>
+            <a:pPr algn="ctr">
+              <a:lnSpc>
+                <a:spcPts val="1500"/>
+              </a:lnSpc>
+              <a:defRPr sz="1100">
+                <a:solidFill>
+                  <a:srgbClr val="94A3B8"/>
+                </a:solidFill>
+                <a:latin typeface="Segoe UI"/>
+              </a:defRPr>
+            </a:pPr>
+            <a:r>
+              <a:t>triageUrgent</a:t>
+            </a:r>
+            <a:br/>
+            <a:r>
+              <a:t>+ defuseChaos</a:t>
+            </a:r>
+            <a:br/>
+            <a:r>
+              <a:t>(no LLM)</a:t>
+            </a:r>
+          </a:p>
+        </p:txBody>
+      </p:sp>
+      <p:sp>
+        <p:nvSpPr>
+          <p:cNvPr id="36" name="Right Arrow 35"/>
+          <p:cNvSpPr/>
+          <p:nvPr/>
+        </p:nvSpPr>
+        <p:spPr>
+          <a:xfrm>
+            <a:off x="8468715" y="3520440"/>
+            <a:ext cx="329184" cy="274320"/>
+          </a:xfrm>
+          <a:prstGeom prst="rightArrow">
+            <a:avLst/>
+          </a:prstGeom>
+          <a:solidFill>
+            <a:srgbClr val="475569"/>
+          </a:solidFill>
+          <a:ln>
+            <a:noFill/>
+          </a:ln>
+          <a:effectLst/>
+        </p:spPr>
+        <p:style>
+          <a:lnRef idx="1">
+            <a:schemeClr val="accent1"/>
+          </a:lnRef>
+          <a:fillRef idx="3">
+            <a:schemeClr val="accent1"/>
+          </a:fillRef>
+          <a:effectRef idx="2">
+            <a:schemeClr val="accent1"/>
+          </a:effectRef>
+          <a:fontRef idx="minor">
+            <a:schemeClr val="lt1"/>
+          </a:fontRef>
+        </p:style>
+        <p:txBody>
+          <a:bodyPr rtlCol="0" anchor="ctr"/>
+          <a:lstStyle/>
+          <a:p>
+            <a:pPr algn="ctr"/>
+          </a:p>
+        </p:txBody>
+      </p:sp>
+      <p:sp>
+        <p:nvSpPr>
+          <p:cNvPr id="37" name="Rounded Rectangle 36"/>
+          <p:cNvSpPr/>
+          <p:nvPr/>
+        </p:nvSpPr>
+        <p:spPr>
+          <a:xfrm>
+            <a:off x="8816187" y="2194560"/>
+            <a:ext cx="1325880" cy="2926080"/>
           </a:xfrm>
           <a:prstGeom prst="roundRect">
             <a:avLst>
@@ -4598,13 +5182,13 @@
       </p:sp>
       <p:sp>
         <p:nvSpPr>
-          <p:cNvPr id="25" name="Oval 24"/>
+          <p:cNvPr id="38" name="Oval 37"/>
           <p:cNvSpPr/>
           <p:nvPr/>
         </p:nvSpPr>
         <p:spPr>
           <a:xfrm>
-            <a:off x="8793327" y="2468880"/>
+            <a:off x="9227667" y="2468880"/>
             <a:ext cx="502920" cy="502920"/>
           </a:xfrm>
           <a:prstGeom prst="ellipse">
@@ -4645,27 +5229,27 @@
               </a:spcAft>
               <a:defRPr sz="2000" b="1">
                 <a:solidFill>
-                  <a:srgbClr val="0F172A"/>
+                  <a:srgbClr val="F8FAFC"/>
                 </a:solidFill>
                 <a:latin typeface="Segoe UI"/>
               </a:defRPr>
             </a:pPr>
             <a:r>
-              <a:t>5</a:t>
-            </a:r>
-          </a:p>
-        </p:txBody>
-      </p:sp>
-      <p:sp>
-        <p:nvSpPr>
-          <p:cNvPr id="26" name="TextBox 25"/>
+              <a:t>6</a:t>
+            </a:r>
+          </a:p>
+        </p:txBody>
+      </p:sp>
+      <p:sp>
+        <p:nvSpPr>
+          <p:cNvPr id="39" name="TextBox 38"/>
           <p:cNvSpPr txBox="1"/>
           <p:nvPr/>
         </p:nvSpPr>
         <p:spPr>
           <a:xfrm>
-            <a:off x="8381847" y="3154680"/>
-            <a:ext cx="1325880" cy="457200"/>
+            <a:off x="8889339" y="3154680"/>
+            <a:ext cx="1179576" cy="594360"/>
           </a:xfrm>
           <a:prstGeom prst="rect">
             <a:avLst/>
@@ -4679,7 +5263,7 @@
           <a:lstStyle/>
           <a:p>
             <a:pPr algn="ctr">
-              <a:defRPr sz="1500" b="1">
+              <a:defRPr sz="1400" b="1">
                 <a:solidFill>
                   <a:srgbClr val="F8FAFC"/>
                 </a:solidFill>
@@ -4687,21 +5271,21 @@
               </a:defRPr>
             </a:pPr>
             <a:r>
-              <a:t>AI Agents</a:t>
-            </a:r>
-          </a:p>
-        </p:txBody>
-      </p:sp>
-      <p:sp>
-        <p:nvSpPr>
-          <p:cNvPr id="27" name="TextBox 26"/>
+              <a:t>Supervisor + 6</a:t>
+            </a:r>
+          </a:p>
+        </p:txBody>
+      </p:sp>
+      <p:sp>
+        <p:nvSpPr>
+          <p:cNvPr id="40" name="TextBox 39"/>
           <p:cNvSpPr txBox="1"/>
           <p:nvPr/>
         </p:nvSpPr>
         <p:spPr>
           <a:xfrm>
-            <a:off x="8381847" y="3657600"/>
-            <a:ext cx="1325880" cy="1097280"/>
+            <a:off x="8889339" y="3749040"/>
+            <a:ext cx="1179576" cy="1280160"/>
           </a:xfrm>
           <a:prstGeom prst="rect">
             <a:avLst/>
@@ -4716,9 +5300,9 @@
           <a:p>
             <a:pPr algn="ctr">
               <a:lnSpc>
-                <a:spcPts val="1800"/>
+                <a:spcPts val="1500"/>
               </a:lnSpc>
-              <a:defRPr sz="1300">
+              <a:defRPr sz="1100">
                 <a:solidFill>
                   <a:srgbClr val="94A3B8"/>
                 </a:solidFill>
@@ -4726,10 +5310,14 @@
               </a:defRPr>
             </a:pPr>
             <a:r>
-              <a:t>5 Sub-Agents</a:t>
+              <a:t>LangChain4j</a:t>
             </a:r>
             <a:br/>
             <a:r>
+              <a:t>6 Sub-Agents</a:t>
+            </a:r>
+            <a:br/>
+            <a:r>
               <a:t>+ Fallback</a:t>
             </a:r>
           </a:p>
@@ -4737,14 +5325,14 @@
       </p:sp>
       <p:sp>
         <p:nvSpPr>
-          <p:cNvPr id="28" name="Right Arrow 27"/>
+          <p:cNvPr id="41" name="Right Arrow 40"/>
           <p:cNvSpPr/>
           <p:nvPr/>
         </p:nvSpPr>
         <p:spPr>
           <a:xfrm>
-            <a:off x="9817455" y="3429000"/>
-            <a:ext cx="420624" cy="274320"/>
+            <a:off x="10160355" y="3520440"/>
+            <a:ext cx="329184" cy="274320"/>
           </a:xfrm>
           <a:prstGeom prst="rightArrow">
             <a:avLst/>
@@ -4781,14 +5369,14 @@
       </p:sp>
       <p:sp>
         <p:nvSpPr>
-          <p:cNvPr id="29" name="Rounded Rectangle 28"/>
+          <p:cNvPr id="42" name="Rounded Rectangle 41"/>
           <p:cNvSpPr/>
           <p:nvPr/>
         </p:nvSpPr>
         <p:spPr>
           <a:xfrm>
-            <a:off x="10256367" y="2194560"/>
-            <a:ext cx="1508760" cy="2743200"/>
+            <a:off x="10507827" y="2194560"/>
+            <a:ext cx="1325880" cy="2926080"/>
           </a:xfrm>
           <a:prstGeom prst="roundRect">
             <a:avLst>
@@ -4829,13 +5417,13 @@
       </p:sp>
       <p:sp>
         <p:nvSpPr>
-          <p:cNvPr id="30" name="Oval 29"/>
+          <p:cNvPr id="43" name="Oval 42"/>
           <p:cNvSpPr/>
           <p:nvPr/>
         </p:nvSpPr>
         <p:spPr>
           <a:xfrm>
-            <a:off x="10759287" y="2468880"/>
+            <a:off x="10919307" y="2468880"/>
             <a:ext cx="502920" cy="502920"/>
           </a:xfrm>
           <a:prstGeom prst="ellipse">
@@ -4882,21 +5470,21 @@
               </a:defRPr>
             </a:pPr>
             <a:r>
-              <a:t>6</a:t>
-            </a:r>
-          </a:p>
-        </p:txBody>
-      </p:sp>
-      <p:sp>
-        <p:nvSpPr>
-          <p:cNvPr id="31" name="TextBox 30"/>
+              <a:t>7</a:t>
+            </a:r>
+          </a:p>
+        </p:txBody>
+      </p:sp>
+      <p:sp>
+        <p:nvSpPr>
+          <p:cNvPr id="44" name="TextBox 43"/>
           <p:cNvSpPr txBox="1"/>
           <p:nvPr/>
         </p:nvSpPr>
         <p:spPr>
           <a:xfrm>
-            <a:off x="10347807" y="3154680"/>
-            <a:ext cx="1325880" cy="457200"/>
+            <a:off x="10580979" y="3154680"/>
+            <a:ext cx="1179576" cy="594360"/>
           </a:xfrm>
           <a:prstGeom prst="rect">
             <a:avLst/>
@@ -4910,7 +5498,7 @@
           <a:lstStyle/>
           <a:p>
             <a:pPr algn="ctr">
-              <a:defRPr sz="1500" b="1">
+              <a:defRPr sz="1400" b="1">
                 <a:solidFill>
                   <a:srgbClr val="F8FAFC"/>
                 </a:solidFill>
@@ -4925,14 +5513,14 @@
       </p:sp>
       <p:sp>
         <p:nvSpPr>
-          <p:cNvPr id="32" name="TextBox 31"/>
+          <p:cNvPr id="45" name="TextBox 44"/>
           <p:cNvSpPr txBox="1"/>
           <p:nvPr/>
         </p:nvSpPr>
         <p:spPr>
           <a:xfrm>
-            <a:off x="10347807" y="3657600"/>
-            <a:ext cx="1325880" cy="1097280"/>
+            <a:off x="10580979" y="3749040"/>
+            <a:ext cx="1179576" cy="1280160"/>
           </a:xfrm>
           <a:prstGeom prst="rect">
             <a:avLst/>
@@ -4947,9 +5535,9 @@
           <a:p>
             <a:pPr algn="ctr">
               <a:lnSpc>
-                <a:spcPts val="1800"/>
+                <a:spcPts val="1500"/>
               </a:lnSpc>
-              <a:defRPr sz="1300">
+              <a:defRPr sz="1100">
                 <a:solidFill>
                   <a:srgbClr val="94A3B8"/>
                 </a:solidFill>
@@ -4957,11 +5545,47 @@
               </a:defRPr>
             </a:pPr>
             <a:r>
-              <a:t>Mutations</a:t>
+              <a:t>Apply · Recalc</a:t>
             </a:r>
             <a:br/>
             <a:r>
-              <a:t>+ Persistence</a:t>
+              <a:t>+ Persist</a:t>
+            </a:r>
+          </a:p>
+        </p:txBody>
+      </p:sp>
+      <p:sp>
+        <p:nvSpPr>
+          <p:cNvPr id="46" name="TextBox 45"/>
+          <p:cNvSpPr txBox="1"/>
+          <p:nvPr/>
+        </p:nvSpPr>
+        <p:spPr>
+          <a:xfrm>
+            <a:off x="0" y="5943600"/>
+            <a:ext cx="12191695" cy="274320"/>
+          </a:xfrm>
+          <a:prstGeom prst="rect">
+            <a:avLst/>
+          </a:prstGeom>
+          <a:noFill/>
+        </p:spPr>
+        <p:txBody>
+          <a:bodyPr wrap="none">
+            <a:spAutoFit/>
+          </a:bodyPr>
+          <a:lstStyle/>
+          <a:p>
+            <a:pPr algn="ctr">
+              <a:defRPr sz="1200">
+                <a:solidFill>
+                  <a:srgbClr val="475569"/>
+                </a:solidFill>
+                <a:latin typeface="Segoe UI"/>
+              </a:defRPr>
+            </a:pPr>
+            <a:r>
+              <a:t>BEFORE score (1–4)  →  Pre-pass guarantees the drop (5)  →  AI rebalances (6)  →  Recalculate + persist (7)</a:t>
             </a:r>
           </a:p>
         </p:txBody>

</xml_diff>